<commit_message>
Combined notices, image SOP with environments, pairing tiers and priority pairings
- Footers show classification and status together (Confidential · Draft · Do not use) on decks, proposals, reports and every contract page; per-slide stricter status
- Environment backgrounds can use any Part 6 photo source (Ocean project, stock, AI); dividers accept project photos
- Pairing tiers (text, large, display, tonal) enforced; usage map for all 30 pairings in tokens and decisions.md Part 12
- Olive + Honeydew, Sage + Sprig and Sprig + Crimson placed in the recipes and catalog; pull-quote layout; soft environment maps for display pairings
</commit_message>
<xml_diff>
--- a/output/pptx/ocean-deck-recipe-10.pptx
+++ b/output/pptx/ocean-deck-recipe-10.pptx
@@ -2377,22 +2377,22 @@
         </p:nvSpPr>
         <p:spPr>
           <a:xfrm>
-            <a:off x="711200" y="5715000"/>
-            <a:ext cx="10769295" cy="201168"/>
-          </a:xfrm>
-          <a:prstGeom prst="rect">
-            <a:avLst/>
-          </a:prstGeom>
-          <a:noFill/>
-          <a:ln/>
-        </p:spPr>
-        <p:txBody>
-          <a:bodyPr wrap="square" lIns="0" tIns="0" rIns="0" bIns="0" rtlCol="0" anchor="t"/>
-          <a:lstStyle/>
-          <a:p>
-            <a:pPr algn="l" indent="0" marL="0">
-              <a:lnSpc>
-                <a:spcPts val="1116"/>
+            <a:off x="711200" y="5537200"/>
+            <a:ext cx="10769295" cy="402336"/>
+          </a:xfrm>
+          <a:prstGeom prst="rect">
+            <a:avLst/>
+          </a:prstGeom>
+          <a:noFill/>
+          <a:ln/>
+        </p:spPr>
+        <p:txBody>
+          <a:bodyPr wrap="square" lIns="0" tIns="0" rIns="0" bIns="0" rtlCol="0" anchor="t"/>
+          <a:lstStyle/>
+          <a:p>
+            <a:pPr algn="l" indent="0" marL="0">
+              <a:lnSpc>
+                <a:spcPts val="1300"/>
               </a:lnSpc>
               <a:buNone/>
             </a:pPr>
@@ -2405,7 +2405,27 @@
                 <a:ea typeface="Stack Sans Headline Light" pitchFamily="34" charset="-122"/>
                 <a:cs typeface="Stack Sans Headline Light" pitchFamily="34" charset="-120"/>
               </a:rPr>
-              <a:t>Design specimen with illustrative figures and representative images. Do not use for any commercial purpose.</a:t>
+              <a:t>Confidential. Prepared for Ocean RCS. Do not copy, forward or distribute without the written consent of Ocean RCS. Design specimen with illustrative figures and representative images. Do not use for any</a:t>
+            </a:r>
+            <a:endParaRPr lang="en-US" sz="900" dirty="0"/>
+          </a:p>
+          <a:p>
+            <a:pPr algn="l" indent="0" marL="0">
+              <a:lnSpc>
+                <a:spcPts val="1300"/>
+              </a:lnSpc>
+              <a:buNone/>
+            </a:pPr>
+            <a:r>
+              <a:rPr lang="en-US" sz="900" dirty="0">
+                <a:solidFill>
+                  <a:srgbClr val="F3FBF8"/>
+                </a:solidFill>
+                <a:latin typeface="Stack Sans Headline Light" pitchFamily="34" charset="0"/>
+                <a:ea typeface="Stack Sans Headline Light" pitchFamily="34" charset="-122"/>
+                <a:cs typeface="Stack Sans Headline Light" pitchFamily="34" charset="-120"/>
+              </a:rPr>
+              <a:t>commercial purpose.</a:t>
             </a:r>
             <a:endParaRPr lang="en-US" sz="900" dirty="0"/>
           </a:p>
@@ -4574,51 +4594,9 @@
           </a:ln>
         </p:spPr>
       </p:sp>
-      <p:sp>
-        <p:nvSpPr>
-          <p:cNvPr id="29" name="ocean:footer"/>
-          <p:cNvSpPr/>
-          <p:nvPr/>
-        </p:nvSpPr>
-        <p:spPr>
-          <a:xfrm>
-            <a:off x="548640" y="6419088"/>
-            <a:ext cx="7315200" cy="182880"/>
-          </a:xfrm>
-          <a:prstGeom prst="rect">
-            <a:avLst/>
-          </a:prstGeom>
-          <a:noFill/>
-          <a:ln/>
-        </p:spPr>
-        <p:txBody>
-          <a:bodyPr wrap="square" lIns="0" tIns="0" rIns="0" bIns="0" rtlCol="0" anchor="t"/>
-          <a:lstStyle/>
-          <a:p>
-            <a:pPr algn="l" indent="0" marL="0">
-              <a:lnSpc>
-                <a:spcPts val="1116"/>
-              </a:lnSpc>
-              <a:buNone/>
-            </a:pPr>
-            <a:r>
-              <a:rPr lang="en-US" sz="900" spc="225" kern="0" dirty="0">
-                <a:solidFill>
-                  <a:srgbClr val="102426"/>
-                </a:solidFill>
-                <a:latin typeface="Stack Sans Headline Light" pitchFamily="34" charset="0"/>
-                <a:ea typeface="Stack Sans Headline Light" pitchFamily="34" charset="-122"/>
-                <a:cs typeface="Stack Sans Headline Light" pitchFamily="34" charset="-120"/>
-              </a:rPr>
-              <a:t>OCEAN RCS · DESIGN SPECIMEN · DO NOT USE</a:t>
-            </a:r>
-            <a:endParaRPr lang="en-US" sz="900" dirty="0"/>
-          </a:p>
-        </p:txBody>
-      </p:sp>
       <p:pic>
         <p:nvPicPr>
-          <p:cNvPr id="30" name="ocean:photo" descr="/home/user/workspace/audit/repo/output/.cache/fit/rooftop-9961c474ed952cad.jpg">    </p:cNvPr>
+          <p:cNvPr id="29" name="ocean:photo" descr="/home/user/workspace/audit/repo/output/.cache/fit/rooftop-9961c474ed952cad.jpg">    </p:cNvPr>
           <p:cNvPicPr>
             <a:picLocks noChangeAspect="1"/>
           </p:cNvPicPr>
@@ -4642,7 +4620,7 @@
       </p:pic>
       <p:sp>
         <p:nvSpPr>
-          <p:cNvPr id="31" name="Shape 27"/>
+          <p:cNvPr id="30" name="Shape 26"/>
           <p:cNvSpPr/>
           <p:nvPr/>
         </p:nvSpPr>
@@ -4667,7 +4645,7 @@
       </p:sp>
       <p:sp>
         <p:nvSpPr>
-          <p:cNvPr id="32" name="ocean:frame"/>
+          <p:cNvPr id="31" name="ocean:frame"/>
           <p:cNvSpPr/>
           <p:nvPr/>
         </p:nvSpPr>
@@ -4728,7 +4706,7 @@
       </p:sp>
       <p:sp>
         <p:nvSpPr>
-          <p:cNvPr id="33" name="Shape 29"/>
+          <p:cNvPr id="32" name="Shape 28"/>
           <p:cNvSpPr/>
           <p:nvPr/>
         </p:nvSpPr>
@@ -4753,7 +4731,7 @@
       </p:sp>
       <p:sp>
         <p:nvSpPr>
-          <p:cNvPr id="34" name="ocean:label"/>
+          <p:cNvPr id="33" name="ocean:label"/>
           <p:cNvSpPr/>
           <p:nvPr/>
         </p:nvSpPr>
@@ -4795,7 +4773,7 @@
       </p:sp>
       <p:sp>
         <p:nvSpPr>
-          <p:cNvPr id="35" name="ocean:body"/>
+          <p:cNvPr id="34" name="ocean:body"/>
           <p:cNvSpPr/>
           <p:nvPr/>
         </p:nvSpPr>
@@ -4837,7 +4815,7 @@
       </p:sp>
       <p:sp>
         <p:nvSpPr>
-          <p:cNvPr id="36" name="ocean:frame"/>
+          <p:cNvPr id="35" name="ocean:frame"/>
           <p:cNvSpPr/>
           <p:nvPr/>
         </p:nvSpPr>
@@ -4898,7 +4876,7 @@
       </p:sp>
       <p:sp>
         <p:nvSpPr>
-          <p:cNvPr id="37" name="Shape 33"/>
+          <p:cNvPr id="36" name="Shape 32"/>
           <p:cNvSpPr/>
           <p:nvPr/>
         </p:nvSpPr>
@@ -4923,7 +4901,7 @@
       </p:sp>
       <p:sp>
         <p:nvSpPr>
-          <p:cNvPr id="38" name="Shape 34"/>
+          <p:cNvPr id="37" name="Shape 33"/>
           <p:cNvSpPr/>
           <p:nvPr/>
         </p:nvSpPr>
@@ -4948,7 +4926,7 @@
       </p:sp>
       <p:sp>
         <p:nvSpPr>
-          <p:cNvPr id="39" name="ocean:label"/>
+          <p:cNvPr id="38" name="ocean:label"/>
           <p:cNvSpPr/>
           <p:nvPr/>
         </p:nvSpPr>
@@ -4990,7 +4968,7 @@
       </p:sp>
       <p:sp>
         <p:nvSpPr>
-          <p:cNvPr id="40" name="ocean:body"/>
+          <p:cNvPr id="39" name="ocean:body"/>
           <p:cNvSpPr/>
           <p:nvPr/>
         </p:nvSpPr>
@@ -5032,7 +5010,7 @@
       </p:sp>
       <p:sp>
         <p:nvSpPr>
-          <p:cNvPr id="41" name="ocean:frame"/>
+          <p:cNvPr id="40" name="ocean:frame"/>
           <p:cNvSpPr/>
           <p:nvPr/>
         </p:nvSpPr>
@@ -5093,7 +5071,7 @@
       </p:sp>
       <p:sp>
         <p:nvSpPr>
-          <p:cNvPr id="42" name="Shape 38"/>
+          <p:cNvPr id="41" name="Shape 37"/>
           <p:cNvSpPr/>
           <p:nvPr/>
         </p:nvSpPr>
@@ -5118,7 +5096,7 @@
       </p:sp>
       <p:sp>
         <p:nvSpPr>
-          <p:cNvPr id="43" name="Shape 39"/>
+          <p:cNvPr id="42" name="Shape 38"/>
           <p:cNvSpPr/>
           <p:nvPr/>
         </p:nvSpPr>
@@ -5143,7 +5121,7 @@
       </p:sp>
       <p:sp>
         <p:nvSpPr>
-          <p:cNvPr id="44" name="Shape 40"/>
+          <p:cNvPr id="43" name="Shape 39"/>
           <p:cNvSpPr/>
           <p:nvPr/>
         </p:nvSpPr>
@@ -5168,7 +5146,7 @@
       </p:sp>
       <p:sp>
         <p:nvSpPr>
-          <p:cNvPr id="45" name="ocean:label"/>
+          <p:cNvPr id="44" name="ocean:label"/>
           <p:cNvSpPr/>
           <p:nvPr/>
         </p:nvSpPr>
@@ -5210,7 +5188,7 @@
       </p:sp>
       <p:sp>
         <p:nvSpPr>
-          <p:cNvPr id="46" name="ocean:body"/>
+          <p:cNvPr id="45" name="ocean:body"/>
           <p:cNvSpPr/>
           <p:nvPr/>
         </p:nvSpPr>
@@ -5252,7 +5230,7 @@
       </p:sp>
       <p:sp>
         <p:nvSpPr>
-          <p:cNvPr id="47" name="ocean:body"/>
+          <p:cNvPr id="46" name="ocean:body"/>
           <p:cNvSpPr/>
           <p:nvPr/>
         </p:nvSpPr>
@@ -5289,6 +5267,48 @@
               <a:t>Representative image of a comparable rooftop array.</a:t>
             </a:r>
             <a:endParaRPr lang="en-US" sz="1200" dirty="0"/>
+          </a:p>
+        </p:txBody>
+      </p:sp>
+      <p:sp>
+        <p:nvSpPr>
+          <p:cNvPr id="47" name="ocean:footer"/>
+          <p:cNvSpPr/>
+          <p:nvPr/>
+        </p:nvSpPr>
+        <p:spPr>
+          <a:xfrm>
+            <a:off x="548640" y="6419088"/>
+            <a:ext cx="7315200" cy="182880"/>
+          </a:xfrm>
+          <a:prstGeom prst="rect">
+            <a:avLst/>
+          </a:prstGeom>
+          <a:noFill/>
+          <a:ln/>
+        </p:spPr>
+        <p:txBody>
+          <a:bodyPr wrap="square" lIns="0" tIns="0" rIns="0" bIns="0" rtlCol="0" anchor="t"/>
+          <a:lstStyle/>
+          <a:p>
+            <a:pPr algn="l" indent="0" marL="0">
+              <a:lnSpc>
+                <a:spcPts val="1116"/>
+              </a:lnSpc>
+              <a:buNone/>
+            </a:pPr>
+            <a:r>
+              <a:rPr lang="en-US" sz="900" spc="225" kern="0" dirty="0">
+                <a:solidFill>
+                  <a:srgbClr val="102426"/>
+                </a:solidFill>
+                <a:latin typeface="Stack Sans Headline Light" pitchFamily="34" charset="0"/>
+                <a:ea typeface="Stack Sans Headline Light" pitchFamily="34" charset="-122"/>
+                <a:cs typeface="Stack Sans Headline Light" pitchFamily="34" charset="-120"/>
+              </a:rPr>
+              <a:t>OCEAN RCS · CONFIDENTIAL · DESIGN SPECIMEN · DO NOT USE</a:t>
+            </a:r>
+            <a:endParaRPr lang="en-US" sz="900" dirty="0"/>
           </a:p>
         </p:txBody>
       </p:sp>
@@ -6256,49 +6276,7 @@
       </p:sp>
       <p:sp>
         <p:nvSpPr>
-          <p:cNvPr id="29" name="ocean:footer"/>
-          <p:cNvSpPr/>
-          <p:nvPr/>
-        </p:nvSpPr>
-        <p:spPr>
-          <a:xfrm>
-            <a:off x="548640" y="6419088"/>
-            <a:ext cx="7315200" cy="182880"/>
-          </a:xfrm>
-          <a:prstGeom prst="rect">
-            <a:avLst/>
-          </a:prstGeom>
-          <a:noFill/>
-          <a:ln/>
-        </p:spPr>
-        <p:txBody>
-          <a:bodyPr wrap="square" lIns="0" tIns="0" rIns="0" bIns="0" rtlCol="0" anchor="t"/>
-          <a:lstStyle/>
-          <a:p>
-            <a:pPr algn="l" indent="0" marL="0">
-              <a:lnSpc>
-                <a:spcPts val="1116"/>
-              </a:lnSpc>
-              <a:buNone/>
-            </a:pPr>
-            <a:r>
-              <a:rPr lang="en-US" sz="900" spc="225" kern="0" dirty="0">
-                <a:solidFill>
-                  <a:srgbClr val="102426"/>
-                </a:solidFill>
-                <a:latin typeface="Stack Sans Headline Light" pitchFamily="34" charset="0"/>
-                <a:ea typeface="Stack Sans Headline Light" pitchFamily="34" charset="-122"/>
-                <a:cs typeface="Stack Sans Headline Light" pitchFamily="34" charset="-120"/>
-              </a:rPr>
-              <a:t>OCEAN RCS · DESIGN SPECIMEN · DO NOT USE</a:t>
-            </a:r>
-            <a:endParaRPr lang="en-US" sz="900" dirty="0"/>
-          </a:p>
-        </p:txBody>
-      </p:sp>
-      <p:sp>
-        <p:nvSpPr>
-          <p:cNvPr id="30" name="ocean:frame"/>
+          <p:cNvPr id="29" name="ocean:frame"/>
           <p:cNvSpPr/>
           <p:nvPr/>
         </p:nvSpPr>
@@ -6359,7 +6337,7 @@
       </p:sp>
       <p:sp>
         <p:nvSpPr>
-          <p:cNvPr id="31" name="Shape 28"/>
+          <p:cNvPr id="30" name="Shape 27"/>
           <p:cNvSpPr/>
           <p:nvPr/>
         </p:nvSpPr>
@@ -6384,7 +6362,7 @@
       </p:sp>
       <p:sp>
         <p:nvSpPr>
-          <p:cNvPr id="32" name="ocean:label"/>
+          <p:cNvPr id="31" name="ocean:label"/>
           <p:cNvSpPr/>
           <p:nvPr/>
         </p:nvSpPr>
@@ -6426,7 +6404,7 @@
       </p:sp>
       <p:sp>
         <p:nvSpPr>
-          <p:cNvPr id="33" name="ocean:metric"/>
+          <p:cNvPr id="32" name="ocean:metric"/>
           <p:cNvSpPr/>
           <p:nvPr/>
         </p:nvSpPr>
@@ -6468,7 +6446,7 @@
       </p:sp>
       <p:sp>
         <p:nvSpPr>
-          <p:cNvPr id="34" name="ocean:label"/>
+          <p:cNvPr id="33" name="ocean:label"/>
           <p:cNvSpPr/>
           <p:nvPr/>
         </p:nvSpPr>
@@ -6510,7 +6488,7 @@
       </p:sp>
       <p:sp>
         <p:nvSpPr>
-          <p:cNvPr id="35" name="ocean:frame"/>
+          <p:cNvPr id="34" name="ocean:frame"/>
           <p:cNvSpPr/>
           <p:nvPr/>
         </p:nvSpPr>
@@ -6571,7 +6549,7 @@
       </p:sp>
       <p:sp>
         <p:nvSpPr>
-          <p:cNvPr id="36" name="Shape 33"/>
+          <p:cNvPr id="35" name="Shape 32"/>
           <p:cNvSpPr/>
           <p:nvPr/>
         </p:nvSpPr>
@@ -6596,7 +6574,7 @@
       </p:sp>
       <p:sp>
         <p:nvSpPr>
-          <p:cNvPr id="37" name="Shape 34"/>
+          <p:cNvPr id="36" name="Shape 33"/>
           <p:cNvSpPr/>
           <p:nvPr/>
         </p:nvSpPr>
@@ -6621,7 +6599,7 @@
       </p:sp>
       <p:sp>
         <p:nvSpPr>
-          <p:cNvPr id="38" name="ocean:label"/>
+          <p:cNvPr id="37" name="ocean:label"/>
           <p:cNvSpPr/>
           <p:nvPr/>
         </p:nvSpPr>
@@ -6663,7 +6641,7 @@
       </p:sp>
       <p:sp>
         <p:nvSpPr>
-          <p:cNvPr id="39" name="ocean:metric"/>
+          <p:cNvPr id="38" name="ocean:metric"/>
           <p:cNvSpPr/>
           <p:nvPr/>
         </p:nvSpPr>
@@ -6705,7 +6683,7 @@
       </p:sp>
       <p:sp>
         <p:nvSpPr>
-          <p:cNvPr id="40" name="ocean:label"/>
+          <p:cNvPr id="39" name="ocean:label"/>
           <p:cNvSpPr/>
           <p:nvPr/>
         </p:nvSpPr>
@@ -6747,7 +6725,7 @@
       </p:sp>
       <p:sp>
         <p:nvSpPr>
-          <p:cNvPr id="41" name="ocean:frame"/>
+          <p:cNvPr id="40" name="ocean:frame"/>
           <p:cNvSpPr/>
           <p:nvPr/>
         </p:nvSpPr>
@@ -6808,7 +6786,7 @@
       </p:sp>
       <p:sp>
         <p:nvSpPr>
-          <p:cNvPr id="42" name="Shape 39"/>
+          <p:cNvPr id="41" name="Shape 38"/>
           <p:cNvSpPr/>
           <p:nvPr/>
         </p:nvSpPr>
@@ -6833,7 +6811,7 @@
       </p:sp>
       <p:sp>
         <p:nvSpPr>
-          <p:cNvPr id="43" name="Shape 40"/>
+          <p:cNvPr id="42" name="Shape 39"/>
           <p:cNvSpPr/>
           <p:nvPr/>
         </p:nvSpPr>
@@ -6858,7 +6836,7 @@
       </p:sp>
       <p:sp>
         <p:nvSpPr>
-          <p:cNvPr id="44" name="Shape 41"/>
+          <p:cNvPr id="43" name="Shape 40"/>
           <p:cNvSpPr/>
           <p:nvPr/>
         </p:nvSpPr>
@@ -6883,7 +6861,7 @@
       </p:sp>
       <p:sp>
         <p:nvSpPr>
-          <p:cNvPr id="45" name="ocean:label"/>
+          <p:cNvPr id="44" name="ocean:label"/>
           <p:cNvSpPr/>
           <p:nvPr/>
         </p:nvSpPr>
@@ -6925,7 +6903,7 @@
       </p:sp>
       <p:sp>
         <p:nvSpPr>
-          <p:cNvPr id="46" name="ocean:metric"/>
+          <p:cNvPr id="45" name="ocean:metric"/>
           <p:cNvSpPr/>
           <p:nvPr/>
         </p:nvSpPr>
@@ -6967,7 +6945,7 @@
       </p:sp>
       <p:sp>
         <p:nvSpPr>
-          <p:cNvPr id="47" name="ocean:label"/>
+          <p:cNvPr id="46" name="ocean:label"/>
           <p:cNvSpPr/>
           <p:nvPr/>
         </p:nvSpPr>
@@ -7009,7 +6987,7 @@
       </p:sp>
       <p:sp>
         <p:nvSpPr>
-          <p:cNvPr id="48" name="ocean:frame"/>
+          <p:cNvPr id="47" name="ocean:frame"/>
           <p:cNvSpPr/>
           <p:nvPr/>
         </p:nvSpPr>
@@ -7073,7 +7051,7 @@
       </p:sp>
       <p:sp>
         <p:nvSpPr>
-          <p:cNvPr id="49" name="Shape 46"/>
+          <p:cNvPr id="48" name="Shape 45"/>
           <p:cNvSpPr/>
           <p:nvPr/>
         </p:nvSpPr>
@@ -7098,7 +7076,7 @@
       </p:sp>
       <p:sp>
         <p:nvSpPr>
-          <p:cNvPr id="50" name="Shape 47"/>
+          <p:cNvPr id="49" name="Shape 46"/>
           <p:cNvSpPr/>
           <p:nvPr/>
         </p:nvSpPr>
@@ -7123,7 +7101,7 @@
       </p:sp>
       <p:sp>
         <p:nvSpPr>
-          <p:cNvPr id="51" name="Shape 48"/>
+          <p:cNvPr id="50" name="Shape 47"/>
           <p:cNvSpPr/>
           <p:nvPr/>
         </p:nvSpPr>
@@ -7148,7 +7126,7 @@
       </p:sp>
       <p:sp>
         <p:nvSpPr>
-          <p:cNvPr id="52" name="Shape 49"/>
+          <p:cNvPr id="51" name="Shape 48"/>
           <p:cNvSpPr/>
           <p:nvPr/>
         </p:nvSpPr>
@@ -7173,7 +7151,7 @@
       </p:sp>
       <p:sp>
         <p:nvSpPr>
-          <p:cNvPr id="53" name="ocean:label"/>
+          <p:cNvPr id="52" name="ocean:label"/>
           <p:cNvSpPr/>
           <p:nvPr/>
         </p:nvSpPr>
@@ -7215,7 +7193,7 @@
       </p:sp>
       <p:sp>
         <p:nvSpPr>
-          <p:cNvPr id="54" name="ocean:metric"/>
+          <p:cNvPr id="53" name="ocean:metric"/>
           <p:cNvSpPr/>
           <p:nvPr/>
         </p:nvSpPr>
@@ -7257,7 +7235,7 @@
       </p:sp>
       <p:sp>
         <p:nvSpPr>
-          <p:cNvPr id="55" name="ocean:label"/>
+          <p:cNvPr id="54" name="ocean:label"/>
           <p:cNvSpPr/>
           <p:nvPr/>
         </p:nvSpPr>
@@ -7299,7 +7277,7 @@
       </p:sp>
       <p:sp>
         <p:nvSpPr>
-          <p:cNvPr id="56" name="ocean:bottom-line"/>
+          <p:cNvPr id="55" name="ocean:bottom-line"/>
           <p:cNvSpPr/>
           <p:nvPr/>
         </p:nvSpPr>
@@ -7363,7 +7341,7 @@
       </p:sp>
       <p:sp>
         <p:nvSpPr>
-          <p:cNvPr id="57" name="Shape 54"/>
+          <p:cNvPr id="56" name="Shape 53"/>
           <p:cNvSpPr/>
           <p:nvPr/>
         </p:nvSpPr>
@@ -7388,7 +7366,7 @@
       </p:sp>
       <p:sp>
         <p:nvSpPr>
-          <p:cNvPr id="58" name="ocean:label"/>
+          <p:cNvPr id="57" name="ocean:label"/>
           <p:cNvSpPr/>
           <p:nvPr/>
         </p:nvSpPr>
@@ -7430,7 +7408,7 @@
       </p:sp>
       <p:sp>
         <p:nvSpPr>
-          <p:cNvPr id="59" name="ocean:bottom-line"/>
+          <p:cNvPr id="58" name="ocean:bottom-line"/>
           <p:cNvSpPr/>
           <p:nvPr/>
         </p:nvSpPr>
@@ -7472,7 +7450,7 @@
       </p:sp>
       <p:sp>
         <p:nvSpPr>
-          <p:cNvPr id="60" name="ocean:footnote"/>
+          <p:cNvPr id="59" name="ocean:footnote"/>
           <p:cNvSpPr/>
           <p:nvPr/>
         </p:nvSpPr>
@@ -7507,6 +7485,48 @@
                 <a:cs typeface="Stack Sans Headline Light" pitchFamily="34" charset="-120"/>
               </a:rPr>
               <a:t>ILLUSTRATIVE FIGURES · SPECIMEN</a:t>
+            </a:r>
+            <a:endParaRPr lang="en-US" sz="900" dirty="0"/>
+          </a:p>
+        </p:txBody>
+      </p:sp>
+      <p:sp>
+        <p:nvSpPr>
+          <p:cNvPr id="60" name="ocean:footer"/>
+          <p:cNvSpPr/>
+          <p:nvPr/>
+        </p:nvSpPr>
+        <p:spPr>
+          <a:xfrm>
+            <a:off x="548640" y="6419088"/>
+            <a:ext cx="7315200" cy="182880"/>
+          </a:xfrm>
+          <a:prstGeom prst="rect">
+            <a:avLst/>
+          </a:prstGeom>
+          <a:noFill/>
+          <a:ln/>
+        </p:spPr>
+        <p:txBody>
+          <a:bodyPr wrap="square" lIns="0" tIns="0" rIns="0" bIns="0" rtlCol="0" anchor="t"/>
+          <a:lstStyle/>
+          <a:p>
+            <a:pPr algn="l" indent="0" marL="0">
+              <a:lnSpc>
+                <a:spcPts val="1116"/>
+              </a:lnSpc>
+              <a:buNone/>
+            </a:pPr>
+            <a:r>
+              <a:rPr lang="en-US" sz="900" spc="225" kern="0" dirty="0">
+                <a:solidFill>
+                  <a:srgbClr val="102426"/>
+                </a:solidFill>
+                <a:latin typeface="Stack Sans Headline Light" pitchFamily="34" charset="0"/>
+                <a:ea typeface="Stack Sans Headline Light" pitchFamily="34" charset="-122"/>
+                <a:cs typeface="Stack Sans Headline Light" pitchFamily="34" charset="-120"/>
+              </a:rPr>
+              <a:t>OCEAN RCS · CONFIDENTIAL · DESIGN SPECIMEN · DO NOT USE</a:t>
             </a:r>
             <a:endParaRPr lang="en-US" sz="900" dirty="0"/>
           </a:p>
@@ -8434,49 +8454,7 @@
       </p:sp>
       <p:sp>
         <p:nvSpPr>
-          <p:cNvPr id="28" name="ocean:footer"/>
-          <p:cNvSpPr/>
-          <p:nvPr/>
-        </p:nvSpPr>
-        <p:spPr>
-          <a:xfrm>
-            <a:off x="548640" y="6419088"/>
-            <a:ext cx="7315200" cy="182880"/>
-          </a:xfrm>
-          <a:prstGeom prst="rect">
-            <a:avLst/>
-          </a:prstGeom>
-          <a:noFill/>
-          <a:ln/>
-        </p:spPr>
-        <p:txBody>
-          <a:bodyPr wrap="square" lIns="0" tIns="0" rIns="0" bIns="0" rtlCol="0" anchor="t"/>
-          <a:lstStyle/>
-          <a:p>
-            <a:pPr algn="l" indent="0" marL="0">
-              <a:lnSpc>
-                <a:spcPts val="1116"/>
-              </a:lnSpc>
-              <a:buNone/>
-            </a:pPr>
-            <a:r>
-              <a:rPr lang="en-US" sz="900" spc="225" kern="0" dirty="0">
-                <a:solidFill>
-                  <a:srgbClr val="1B4039"/>
-                </a:solidFill>
-                <a:latin typeface="Stack Sans Headline Light" pitchFamily="34" charset="0"/>
-                <a:ea typeface="Stack Sans Headline Light" pitchFamily="34" charset="-122"/>
-                <a:cs typeface="Stack Sans Headline Light" pitchFamily="34" charset="-120"/>
-              </a:rPr>
-              <a:t>OCEAN RCS · DESIGN SPECIMEN · DO NOT USE</a:t>
-            </a:r>
-            <a:endParaRPr lang="en-US" sz="900" dirty="0"/>
-          </a:p>
-        </p:txBody>
-      </p:sp>
-      <p:sp>
-        <p:nvSpPr>
-          <p:cNvPr id="29" name="ocean:statement"/>
+          <p:cNvPr id="28" name="ocean:statement"/>
           <p:cNvSpPr/>
           <p:nvPr/>
         </p:nvSpPr>
@@ -8683,7 +8661,7 @@
       </p:sp>
       <p:pic>
         <p:nvPicPr>
-          <p:cNvPr id="30" name="ocean:photo" descr="/home/user/workspace/audit/repo/output/.cache/fit/worker-bde126986fe58e01.jpg">    </p:cNvPr>
+          <p:cNvPr id="29" name="ocean:photo" descr="/home/user/workspace/audit/repo/output/.cache/fit/worker-bde126986fe58e01.jpg">    </p:cNvPr>
           <p:cNvPicPr>
             <a:picLocks noChangeAspect="1"/>
           </p:cNvPicPr>
@@ -8707,7 +8685,7 @@
       </p:pic>
       <p:sp>
         <p:nvSpPr>
-          <p:cNvPr id="31" name="Shape 27"/>
+          <p:cNvPr id="30" name="Shape 26"/>
           <p:cNvSpPr/>
           <p:nvPr/>
         </p:nvSpPr>
@@ -8729,6 +8707,48 @@
             <a:prstDash val="solid"/>
           </a:ln>
         </p:spPr>
+      </p:sp>
+      <p:sp>
+        <p:nvSpPr>
+          <p:cNvPr id="31" name="ocean:footer"/>
+          <p:cNvSpPr/>
+          <p:nvPr/>
+        </p:nvSpPr>
+        <p:spPr>
+          <a:xfrm>
+            <a:off x="548640" y="6419088"/>
+            <a:ext cx="7315200" cy="182880"/>
+          </a:xfrm>
+          <a:prstGeom prst="rect">
+            <a:avLst/>
+          </a:prstGeom>
+          <a:noFill/>
+          <a:ln/>
+        </p:spPr>
+        <p:txBody>
+          <a:bodyPr wrap="square" lIns="0" tIns="0" rIns="0" bIns="0" rtlCol="0" anchor="t"/>
+          <a:lstStyle/>
+          <a:p>
+            <a:pPr algn="l" indent="0" marL="0">
+              <a:lnSpc>
+                <a:spcPts val="1116"/>
+              </a:lnSpc>
+              <a:buNone/>
+            </a:pPr>
+            <a:r>
+              <a:rPr lang="en-US" sz="900" spc="225" kern="0" dirty="0">
+                <a:solidFill>
+                  <a:srgbClr val="1B4039"/>
+                </a:solidFill>
+                <a:latin typeface="Stack Sans Headline Light" pitchFamily="34" charset="0"/>
+                <a:ea typeface="Stack Sans Headline Light" pitchFamily="34" charset="-122"/>
+                <a:cs typeface="Stack Sans Headline Light" pitchFamily="34" charset="-120"/>
+              </a:rPr>
+              <a:t>OCEAN RCS · CONFIDENTIAL · DESIGN SPECIMEN · DO NOT USE</a:t>
+            </a:r>
+            <a:endParaRPr lang="en-US" sz="900" dirty="0"/>
+          </a:p>
+        </p:txBody>
       </p:sp>
     </p:spTree>
   </p:cSld>
@@ -9694,49 +9714,7 @@
       </p:sp>
       <p:sp>
         <p:nvSpPr>
-          <p:cNvPr id="29" name="ocean:footer"/>
-          <p:cNvSpPr/>
-          <p:nvPr/>
-        </p:nvSpPr>
-        <p:spPr>
-          <a:xfrm>
-            <a:off x="548640" y="6419088"/>
-            <a:ext cx="7315200" cy="182880"/>
-          </a:xfrm>
-          <a:prstGeom prst="rect">
-            <a:avLst/>
-          </a:prstGeom>
-          <a:noFill/>
-          <a:ln/>
-        </p:spPr>
-        <p:txBody>
-          <a:bodyPr wrap="square" lIns="0" tIns="0" rIns="0" bIns="0" rtlCol="0" anchor="t"/>
-          <a:lstStyle/>
-          <a:p>
-            <a:pPr algn="l" indent="0" marL="0">
-              <a:lnSpc>
-                <a:spcPts val="1116"/>
-              </a:lnSpc>
-              <a:buNone/>
-            </a:pPr>
-            <a:r>
-              <a:rPr lang="en-US" sz="900" spc="225" kern="0" dirty="0">
-                <a:solidFill>
-                  <a:srgbClr val="1B4039"/>
-                </a:solidFill>
-                <a:latin typeface="Stack Sans Headline Light" pitchFamily="34" charset="0"/>
-                <a:ea typeface="Stack Sans Headline Light" pitchFamily="34" charset="-122"/>
-                <a:cs typeface="Stack Sans Headline Light" pitchFamily="34" charset="-120"/>
-              </a:rPr>
-              <a:t>OCEAN RCS · DESIGN SPECIMEN · DO NOT USE</a:t>
-            </a:r>
-            <a:endParaRPr lang="en-US" sz="900" dirty="0"/>
-          </a:p>
-        </p:txBody>
-      </p:sp>
-      <p:sp>
-        <p:nvSpPr>
-          <p:cNvPr id="30" name="ocean:frame"/>
+          <p:cNvPr id="29" name="ocean:frame"/>
           <p:cNvSpPr/>
           <p:nvPr/>
         </p:nvSpPr>
@@ -9797,7 +9775,7 @@
       </p:sp>
       <p:sp>
         <p:nvSpPr>
-          <p:cNvPr id="31" name="Shape 28"/>
+          <p:cNvPr id="30" name="Shape 27"/>
           <p:cNvSpPr/>
           <p:nvPr/>
         </p:nvSpPr>
@@ -9822,7 +9800,7 @@
       </p:sp>
       <p:sp>
         <p:nvSpPr>
-          <p:cNvPr id="32" name="ocean:label"/>
+          <p:cNvPr id="31" name="ocean:label"/>
           <p:cNvSpPr/>
           <p:nvPr/>
         </p:nvSpPr>
@@ -9864,7 +9842,7 @@
       </p:sp>
       <p:sp>
         <p:nvSpPr>
-          <p:cNvPr id="33" name="ocean:section"/>
+          <p:cNvPr id="32" name="ocean:section"/>
           <p:cNvSpPr/>
           <p:nvPr/>
         </p:nvSpPr>
@@ -9906,7 +9884,7 @@
       </p:sp>
       <p:sp>
         <p:nvSpPr>
-          <p:cNvPr id="34" name="ocean:body"/>
+          <p:cNvPr id="33" name="ocean:body"/>
           <p:cNvSpPr/>
           <p:nvPr/>
         </p:nvSpPr>
@@ -9988,7 +9966,7 @@
       </p:sp>
       <p:sp>
         <p:nvSpPr>
-          <p:cNvPr id="35" name="ocean:frame"/>
+          <p:cNvPr id="34" name="ocean:frame"/>
           <p:cNvSpPr/>
           <p:nvPr/>
         </p:nvSpPr>
@@ -10049,7 +10027,7 @@
       </p:sp>
       <p:sp>
         <p:nvSpPr>
-          <p:cNvPr id="36" name="Shape 33"/>
+          <p:cNvPr id="35" name="Shape 32"/>
           <p:cNvSpPr/>
           <p:nvPr/>
         </p:nvSpPr>
@@ -10074,7 +10052,7 @@
       </p:sp>
       <p:sp>
         <p:nvSpPr>
-          <p:cNvPr id="37" name="Shape 34"/>
+          <p:cNvPr id="36" name="Shape 33"/>
           <p:cNvSpPr/>
           <p:nvPr/>
         </p:nvSpPr>
@@ -10099,7 +10077,7 @@
       </p:sp>
       <p:sp>
         <p:nvSpPr>
-          <p:cNvPr id="38" name="ocean:label"/>
+          <p:cNvPr id="37" name="ocean:label"/>
           <p:cNvSpPr/>
           <p:nvPr/>
         </p:nvSpPr>
@@ -10141,7 +10119,7 @@
       </p:sp>
       <p:sp>
         <p:nvSpPr>
-          <p:cNvPr id="39" name="ocean:section"/>
+          <p:cNvPr id="38" name="ocean:section"/>
           <p:cNvSpPr/>
           <p:nvPr/>
         </p:nvSpPr>
@@ -10183,7 +10161,7 @@
       </p:sp>
       <p:sp>
         <p:nvSpPr>
-          <p:cNvPr id="40" name="ocean:body"/>
+          <p:cNvPr id="39" name="ocean:body"/>
           <p:cNvSpPr/>
           <p:nvPr/>
         </p:nvSpPr>
@@ -10245,7 +10223,7 @@
       </p:sp>
       <p:sp>
         <p:nvSpPr>
-          <p:cNvPr id="41" name="ocean:frame"/>
+          <p:cNvPr id="40" name="ocean:frame"/>
           <p:cNvSpPr/>
           <p:nvPr/>
         </p:nvSpPr>
@@ -10306,7 +10284,7 @@
       </p:sp>
       <p:sp>
         <p:nvSpPr>
-          <p:cNvPr id="42" name="Shape 39"/>
+          <p:cNvPr id="41" name="Shape 38"/>
           <p:cNvSpPr/>
           <p:nvPr/>
         </p:nvSpPr>
@@ -10331,7 +10309,7 @@
       </p:sp>
       <p:sp>
         <p:nvSpPr>
-          <p:cNvPr id="43" name="Shape 40"/>
+          <p:cNvPr id="42" name="Shape 39"/>
           <p:cNvSpPr/>
           <p:nvPr/>
         </p:nvSpPr>
@@ -10356,7 +10334,7 @@
       </p:sp>
       <p:sp>
         <p:nvSpPr>
-          <p:cNvPr id="44" name="Shape 41"/>
+          <p:cNvPr id="43" name="Shape 40"/>
           <p:cNvSpPr/>
           <p:nvPr/>
         </p:nvSpPr>
@@ -10381,7 +10359,7 @@
       </p:sp>
       <p:sp>
         <p:nvSpPr>
-          <p:cNvPr id="45" name="ocean:label"/>
+          <p:cNvPr id="44" name="ocean:label"/>
           <p:cNvSpPr/>
           <p:nvPr/>
         </p:nvSpPr>
@@ -10423,7 +10401,7 @@
       </p:sp>
       <p:sp>
         <p:nvSpPr>
-          <p:cNvPr id="46" name="ocean:section"/>
+          <p:cNvPr id="45" name="ocean:section"/>
           <p:cNvSpPr/>
           <p:nvPr/>
         </p:nvSpPr>
@@ -10465,7 +10443,7 @@
       </p:sp>
       <p:sp>
         <p:nvSpPr>
-          <p:cNvPr id="47" name="ocean:body"/>
+          <p:cNvPr id="46" name="ocean:body"/>
           <p:cNvSpPr/>
           <p:nvPr/>
         </p:nvSpPr>
@@ -10522,6 +10500,48 @@
               <a:t>service, subject to utility approval.</a:t>
             </a:r>
             <a:endParaRPr lang="en-US" sz="1300" dirty="0"/>
+          </a:p>
+        </p:txBody>
+      </p:sp>
+      <p:sp>
+        <p:nvSpPr>
+          <p:cNvPr id="47" name="ocean:footer"/>
+          <p:cNvSpPr/>
+          <p:nvPr/>
+        </p:nvSpPr>
+        <p:spPr>
+          <a:xfrm>
+            <a:off x="548640" y="6419088"/>
+            <a:ext cx="7315200" cy="182880"/>
+          </a:xfrm>
+          <a:prstGeom prst="rect">
+            <a:avLst/>
+          </a:prstGeom>
+          <a:noFill/>
+          <a:ln/>
+        </p:spPr>
+        <p:txBody>
+          <a:bodyPr wrap="square" lIns="0" tIns="0" rIns="0" bIns="0" rtlCol="0" anchor="t"/>
+          <a:lstStyle/>
+          <a:p>
+            <a:pPr algn="l" indent="0" marL="0">
+              <a:lnSpc>
+                <a:spcPts val="1116"/>
+              </a:lnSpc>
+              <a:buNone/>
+            </a:pPr>
+            <a:r>
+              <a:rPr lang="en-US" sz="900" spc="225" kern="0" dirty="0">
+                <a:solidFill>
+                  <a:srgbClr val="1B4039"/>
+                </a:solidFill>
+                <a:latin typeface="Stack Sans Headline Light" pitchFamily="34" charset="0"/>
+                <a:ea typeface="Stack Sans Headline Light" pitchFamily="34" charset="-122"/>
+                <a:cs typeface="Stack Sans Headline Light" pitchFamily="34" charset="-120"/>
+              </a:rPr>
+              <a:t>OCEAN RCS · CONFIDENTIAL · DESIGN SPECIMEN · DO NOT USE</a:t>
+            </a:r>
+            <a:endParaRPr lang="en-US" sz="900" dirty="0"/>
           </a:p>
         </p:txBody>
       </p:sp>
@@ -11507,51 +11527,9 @@
           </a:ln>
         </p:spPr>
       </p:sp>
-      <p:sp>
-        <p:nvSpPr>
-          <p:cNvPr id="29" name="ocean:footer"/>
-          <p:cNvSpPr/>
-          <p:nvPr/>
-        </p:nvSpPr>
-        <p:spPr>
-          <a:xfrm>
-            <a:off x="548640" y="6419088"/>
-            <a:ext cx="7315200" cy="182880"/>
-          </a:xfrm>
-          <a:prstGeom prst="rect">
-            <a:avLst/>
-          </a:prstGeom>
-          <a:noFill/>
-          <a:ln/>
-        </p:spPr>
-        <p:txBody>
-          <a:bodyPr wrap="square" lIns="0" tIns="0" rIns="0" bIns="0" rtlCol="0" anchor="t"/>
-          <a:lstStyle/>
-          <a:p>
-            <a:pPr algn="l" indent="0" marL="0">
-              <a:lnSpc>
-                <a:spcPts val="1116"/>
-              </a:lnSpc>
-              <a:buNone/>
-            </a:pPr>
-            <a:r>
-              <a:rPr lang="en-US" sz="900" spc="225" kern="0" dirty="0">
-                <a:solidFill>
-                  <a:srgbClr val="6E734C"/>
-                </a:solidFill>
-                <a:latin typeface="Stack Sans Headline Light" pitchFamily="34" charset="0"/>
-                <a:ea typeface="Stack Sans Headline Light" pitchFamily="34" charset="-122"/>
-                <a:cs typeface="Stack Sans Headline Light" pitchFamily="34" charset="-120"/>
-              </a:rPr>
-              <a:t>OCEAN RCS · DESIGN SPECIMEN · DO NOT USE</a:t>
-            </a:r>
-            <a:endParaRPr lang="en-US" sz="900" dirty="0"/>
-          </a:p>
-        </p:txBody>
-      </p:sp>
       <p:graphicFrame>
         <p:nvGraphicFramePr>
-          <p:cNvPr id="30" name="Chart 0" descr=""/>
+          <p:cNvPr id="29" name="Chart 0" descr=""/>
           <p:cNvGraphicFramePr/>
           <p:nvPr/>
         </p:nvGraphicFramePr>
@@ -11567,7 +11545,7 @@
       </p:graphicFrame>
       <p:sp>
         <p:nvSpPr>
-          <p:cNvPr id="31" name="Shape 27"/>
+          <p:cNvPr id="30" name="Shape 26"/>
           <p:cNvSpPr/>
           <p:nvPr/>
         </p:nvSpPr>
@@ -11590,7 +11568,7 @@
       </p:sp>
       <p:sp>
         <p:nvSpPr>
-          <p:cNvPr id="32" name="ocean:takeaway"/>
+          <p:cNvPr id="31" name="ocean:takeaway"/>
           <p:cNvSpPr/>
           <p:nvPr/>
         </p:nvSpPr>
@@ -11652,7 +11630,7 @@
       </p:sp>
       <p:sp>
         <p:nvSpPr>
-          <p:cNvPr id="33" name="ocean:bottom-line"/>
+          <p:cNvPr id="32" name="ocean:bottom-line"/>
           <p:cNvSpPr/>
           <p:nvPr/>
         </p:nvSpPr>
@@ -11716,7 +11694,7 @@
       </p:sp>
       <p:sp>
         <p:nvSpPr>
-          <p:cNvPr id="34" name="Shape 30"/>
+          <p:cNvPr id="33" name="Shape 29"/>
           <p:cNvSpPr/>
           <p:nvPr/>
         </p:nvSpPr>
@@ -11741,7 +11719,7 @@
       </p:sp>
       <p:sp>
         <p:nvSpPr>
-          <p:cNvPr id="35" name="ocean:label"/>
+          <p:cNvPr id="34" name="ocean:label"/>
           <p:cNvSpPr/>
           <p:nvPr/>
         </p:nvSpPr>
@@ -11783,7 +11761,7 @@
       </p:sp>
       <p:sp>
         <p:nvSpPr>
-          <p:cNvPr id="36" name="ocean:bottom-line"/>
+          <p:cNvPr id="35" name="ocean:bottom-line"/>
           <p:cNvSpPr/>
           <p:nvPr/>
         </p:nvSpPr>
@@ -11820,6 +11798,48 @@
               <a:t>10-year savings of $819K. Payback in 6.4 years.</a:t>
             </a:r>
             <a:endParaRPr lang="en-US" sz="1500" dirty="0"/>
+          </a:p>
+        </p:txBody>
+      </p:sp>
+      <p:sp>
+        <p:nvSpPr>
+          <p:cNvPr id="36" name="ocean:footer"/>
+          <p:cNvSpPr/>
+          <p:nvPr/>
+        </p:nvSpPr>
+        <p:spPr>
+          <a:xfrm>
+            <a:off x="548640" y="6419088"/>
+            <a:ext cx="7315200" cy="182880"/>
+          </a:xfrm>
+          <a:prstGeom prst="rect">
+            <a:avLst/>
+          </a:prstGeom>
+          <a:noFill/>
+          <a:ln/>
+        </p:spPr>
+        <p:txBody>
+          <a:bodyPr wrap="square" lIns="0" tIns="0" rIns="0" bIns="0" rtlCol="0" anchor="t"/>
+          <a:lstStyle/>
+          <a:p>
+            <a:pPr algn="l" indent="0" marL="0">
+              <a:lnSpc>
+                <a:spcPts val="1116"/>
+              </a:lnSpc>
+              <a:buNone/>
+            </a:pPr>
+            <a:r>
+              <a:rPr lang="en-US" sz="900" spc="225" kern="0" dirty="0">
+                <a:solidFill>
+                  <a:srgbClr val="6E734C"/>
+                </a:solidFill>
+                <a:latin typeface="Stack Sans Headline Light" pitchFamily="34" charset="0"/>
+                <a:ea typeface="Stack Sans Headline Light" pitchFamily="34" charset="-122"/>
+                <a:cs typeface="Stack Sans Headline Light" pitchFamily="34" charset="-120"/>
+              </a:rPr>
+              <a:t>OCEAN RCS · CONFIDENTIAL · DESIGN SPECIMEN · DO NOT USE</a:t>
+            </a:r>
+            <a:endParaRPr lang="en-US" sz="900" dirty="0"/>
           </a:p>
         </p:txBody>
       </p:sp>
@@ -11995,8 +12015,8 @@
         </p:nvSpPr>
         <p:spPr>
           <a:xfrm>
-            <a:off x="5458968" y="4059936"/>
-            <a:ext cx="6217920" cy="1645920"/>
+            <a:off x="5458968" y="3931920"/>
+            <a:ext cx="6217920" cy="1920240"/>
           </a:xfrm>
           <a:prstGeom prst="rect">
             <a:avLst/>
@@ -13162,33 +13182,33 @@
       </p:sp>
       <p:sp>
         <p:nvSpPr>
-          <p:cNvPr id="29" name="ocean:footer"/>
-          <p:cNvSpPr/>
-          <p:nvPr/>
-        </p:nvSpPr>
-        <p:spPr>
-          <a:xfrm>
-            <a:off x="548640" y="6419088"/>
-            <a:ext cx="7315200" cy="182880"/>
-          </a:xfrm>
-          <a:prstGeom prst="rect">
-            <a:avLst/>
-          </a:prstGeom>
-          <a:noFill/>
-          <a:ln/>
-        </p:spPr>
-        <p:txBody>
-          <a:bodyPr wrap="square" lIns="0" tIns="0" rIns="0" bIns="0" rtlCol="0" anchor="t"/>
-          <a:lstStyle/>
-          <a:p>
-            <a:pPr algn="l" indent="0" marL="0">
-              <a:lnSpc>
-                <a:spcPts val="1116"/>
-              </a:lnSpc>
-              <a:buNone/>
-            </a:pPr>
-            <a:r>
-              <a:rPr lang="en-US" sz="900" spc="225" kern="0" dirty="0">
+          <p:cNvPr id="29" name="ocean:label"/>
+          <p:cNvSpPr/>
+          <p:nvPr/>
+        </p:nvSpPr>
+        <p:spPr>
+          <a:xfrm>
+            <a:off x="548640" y="3044952"/>
+            <a:ext cx="5120640" cy="201168"/>
+          </a:xfrm>
+          <a:prstGeom prst="rect">
+            <a:avLst/>
+          </a:prstGeom>
+          <a:noFill/>
+          <a:ln/>
+        </p:spPr>
+        <p:txBody>
+          <a:bodyPr wrap="square" lIns="0" tIns="0" rIns="0" bIns="0" rtlCol="0" anchor="t"/>
+          <a:lstStyle/>
+          <a:p>
+            <a:pPr algn="l" indent="0" marL="0">
+              <a:lnSpc>
+                <a:spcPts val="1302"/>
+              </a:lnSpc>
+              <a:buNone/>
+            </a:pPr>
+            <a:r>
+              <a:rPr lang="en-US" sz="1050" spc="263" kern="0" dirty="0">
                 <a:solidFill>
                   <a:srgbClr val="0B1617"/>
                 </a:solidFill>
@@ -13196,41 +13216,41 @@
                 <a:ea typeface="Stack Sans Headline Light" pitchFamily="34" charset="-122"/>
                 <a:cs typeface="Stack Sans Headline Light" pitchFamily="34" charset="-120"/>
               </a:rPr>
-              <a:t>OCEAN RCS · DESIGN SPECIMEN · DO NOT USE</a:t>
-            </a:r>
-            <a:endParaRPr lang="en-US" sz="900" dirty="0"/>
-          </a:p>
-        </p:txBody>
-      </p:sp>
-      <p:sp>
-        <p:nvSpPr>
-          <p:cNvPr id="30" name="ocean:label"/>
-          <p:cNvSpPr/>
-          <p:nvPr/>
-        </p:nvSpPr>
-        <p:spPr>
-          <a:xfrm>
-            <a:off x="548640" y="3044952"/>
-            <a:ext cx="5120640" cy="201168"/>
-          </a:xfrm>
-          <a:prstGeom prst="rect">
-            <a:avLst/>
-          </a:prstGeom>
-          <a:noFill/>
-          <a:ln/>
-        </p:spPr>
-        <p:txBody>
-          <a:bodyPr wrap="square" lIns="0" tIns="0" rIns="0" bIns="0" rtlCol="0" anchor="t"/>
-          <a:lstStyle/>
-          <a:p>
-            <a:pPr algn="l" indent="0" marL="0">
-              <a:lnSpc>
-                <a:spcPts val="1302"/>
-              </a:lnSpc>
-              <a:buNone/>
-            </a:pPr>
-            <a:r>
-              <a:rPr lang="en-US" sz="1050" spc="263" kern="0" dirty="0">
+              <a:t>VERIFIED PROJECT AMOUNT</a:t>
+            </a:r>
+            <a:endParaRPr lang="en-US" sz="1050" dirty="0"/>
+          </a:p>
+        </p:txBody>
+      </p:sp>
+      <p:sp>
+        <p:nvSpPr>
+          <p:cNvPr id="30" name="ocean:metric"/>
+          <p:cNvSpPr/>
+          <p:nvPr/>
+        </p:nvSpPr>
+        <p:spPr>
+          <a:xfrm>
+            <a:off x="521208" y="3319272"/>
+            <a:ext cx="5120640" cy="868680"/>
+          </a:xfrm>
+          <a:prstGeom prst="rect">
+            <a:avLst/>
+          </a:prstGeom>
+          <a:noFill/>
+          <a:ln/>
+        </p:spPr>
+        <p:txBody>
+          <a:bodyPr wrap="square" lIns="0" tIns="0" rIns="0" bIns="0" rtlCol="0" anchor="t"/>
+          <a:lstStyle/>
+          <a:p>
+            <a:pPr algn="l" indent="0" marL="0">
+              <a:lnSpc>
+                <a:spcPts val="6400"/>
+              </a:lnSpc>
+              <a:buNone/>
+            </a:pPr>
+            <a:r>
+              <a:rPr lang="en-US" sz="6000" spc="-120" kern="0" dirty="0">
                 <a:solidFill>
                   <a:srgbClr val="0B1617"/>
                 </a:solidFill>
@@ -13238,48 +13258,6 @@
                 <a:ea typeface="Stack Sans Headline Light" pitchFamily="34" charset="-122"/>
                 <a:cs typeface="Stack Sans Headline Light" pitchFamily="34" charset="-120"/>
               </a:rPr>
-              <a:t>VERIFIED PROJECT AMOUNT</a:t>
-            </a:r>
-            <a:endParaRPr lang="en-US" sz="1050" dirty="0"/>
-          </a:p>
-        </p:txBody>
-      </p:sp>
-      <p:sp>
-        <p:nvSpPr>
-          <p:cNvPr id="31" name="ocean:metric"/>
-          <p:cNvSpPr/>
-          <p:nvPr/>
-        </p:nvSpPr>
-        <p:spPr>
-          <a:xfrm>
-            <a:off x="521208" y="3319272"/>
-            <a:ext cx="5120640" cy="868680"/>
-          </a:xfrm>
-          <a:prstGeom prst="rect">
-            <a:avLst/>
-          </a:prstGeom>
-          <a:noFill/>
-          <a:ln/>
-        </p:spPr>
-        <p:txBody>
-          <a:bodyPr wrap="square" lIns="0" tIns="0" rIns="0" bIns="0" rtlCol="0" anchor="t"/>
-          <a:lstStyle/>
-          <a:p>
-            <a:pPr algn="l" indent="0" marL="0">
-              <a:lnSpc>
-                <a:spcPts val="6400"/>
-              </a:lnSpc>
-              <a:buNone/>
-            </a:pPr>
-            <a:r>
-              <a:rPr lang="en-US" sz="6000" spc="-120" kern="0" dirty="0">
-                <a:solidFill>
-                  <a:srgbClr val="0B1617"/>
-                </a:solidFill>
-                <a:latin typeface="Stack Sans Headline Light" pitchFamily="34" charset="0"/>
-                <a:ea typeface="Stack Sans Headline Light" pitchFamily="34" charset="-122"/>
-                <a:cs typeface="Stack Sans Headline Light" pitchFamily="34" charset="-120"/>
-              </a:rPr>
               <a:t>[TBD]</a:t>
             </a:r>
             <a:endParaRPr lang="en-US" sz="6000" dirty="0"/>
@@ -13288,7 +13266,7 @@
       </p:sp>
       <p:sp>
         <p:nvSpPr>
-          <p:cNvPr id="32" name="Shape 28"/>
+          <p:cNvPr id="31" name="Shape 27"/>
           <p:cNvSpPr/>
           <p:nvPr/>
         </p:nvSpPr>
@@ -13311,7 +13289,7 @@
       </p:sp>
       <p:sp>
         <p:nvSpPr>
-          <p:cNvPr id="33" name="ocean:body"/>
+          <p:cNvPr id="32" name="ocean:body"/>
           <p:cNvSpPr/>
           <p:nvPr/>
         </p:nvSpPr>
@@ -13353,7 +13331,7 @@
       </p:sp>
       <p:sp>
         <p:nvSpPr>
-          <p:cNvPr id="34" name="ocean:body"/>
+          <p:cNvPr id="33" name="ocean:body"/>
           <p:cNvSpPr/>
           <p:nvPr/>
         </p:nvSpPr>
@@ -13395,7 +13373,7 @@
       </p:sp>
       <p:sp>
         <p:nvSpPr>
-          <p:cNvPr id="35" name="Shape 31"/>
+          <p:cNvPr id="34" name="Shape 30"/>
           <p:cNvSpPr/>
           <p:nvPr/>
         </p:nvSpPr>
@@ -13418,7 +13396,7 @@
       </p:sp>
       <p:sp>
         <p:nvSpPr>
-          <p:cNvPr id="36" name="ocean:body"/>
+          <p:cNvPr id="35" name="ocean:body"/>
           <p:cNvSpPr/>
           <p:nvPr/>
         </p:nvSpPr>
@@ -13460,7 +13438,7 @@
       </p:sp>
       <p:sp>
         <p:nvSpPr>
-          <p:cNvPr id="37" name="ocean:body"/>
+          <p:cNvPr id="36" name="ocean:body"/>
           <p:cNvSpPr/>
           <p:nvPr/>
         </p:nvSpPr>
@@ -13502,7 +13480,7 @@
       </p:sp>
       <p:sp>
         <p:nvSpPr>
-          <p:cNvPr id="38" name="ocean:frame"/>
+          <p:cNvPr id="37" name="ocean:frame"/>
           <p:cNvSpPr/>
           <p:nvPr/>
         </p:nvSpPr>
@@ -13563,7 +13541,7 @@
       </p:sp>
       <p:sp>
         <p:nvSpPr>
-          <p:cNvPr id="39" name="Shape 35"/>
+          <p:cNvPr id="38" name="Shape 34"/>
           <p:cNvSpPr/>
           <p:nvPr/>
         </p:nvSpPr>
@@ -13588,7 +13566,7 @@
       </p:sp>
       <p:sp>
         <p:nvSpPr>
-          <p:cNvPr id="40" name="ocean:label"/>
+          <p:cNvPr id="39" name="ocean:label"/>
           <p:cNvSpPr/>
           <p:nvPr/>
         </p:nvSpPr>
@@ -13630,7 +13608,7 @@
       </p:sp>
       <p:sp>
         <p:nvSpPr>
-          <p:cNvPr id="41" name="ocean:body"/>
+          <p:cNvPr id="40" name="ocean:body"/>
           <p:cNvSpPr/>
           <p:nvPr/>
         </p:nvSpPr>
@@ -13672,7 +13650,7 @@
       </p:sp>
       <p:sp>
         <p:nvSpPr>
-          <p:cNvPr id="42" name="ocean:frame"/>
+          <p:cNvPr id="41" name="ocean:frame"/>
           <p:cNvSpPr/>
           <p:nvPr/>
         </p:nvSpPr>
@@ -13733,7 +13711,7 @@
       </p:sp>
       <p:sp>
         <p:nvSpPr>
-          <p:cNvPr id="43" name="Shape 39"/>
+          <p:cNvPr id="42" name="Shape 38"/>
           <p:cNvSpPr/>
           <p:nvPr/>
         </p:nvSpPr>
@@ -13758,7 +13736,7 @@
       </p:sp>
       <p:sp>
         <p:nvSpPr>
-          <p:cNvPr id="44" name="Shape 40"/>
+          <p:cNvPr id="43" name="Shape 39"/>
           <p:cNvSpPr/>
           <p:nvPr/>
         </p:nvSpPr>
@@ -13783,7 +13761,7 @@
       </p:sp>
       <p:sp>
         <p:nvSpPr>
-          <p:cNvPr id="45" name="ocean:label"/>
+          <p:cNvPr id="44" name="ocean:label"/>
           <p:cNvSpPr/>
           <p:nvPr/>
         </p:nvSpPr>
@@ -13825,7 +13803,7 @@
       </p:sp>
       <p:sp>
         <p:nvSpPr>
-          <p:cNvPr id="46" name="ocean:body"/>
+          <p:cNvPr id="45" name="ocean:body"/>
           <p:cNvSpPr/>
           <p:nvPr/>
         </p:nvSpPr>
@@ -13867,7 +13845,7 @@
       </p:sp>
       <p:sp>
         <p:nvSpPr>
-          <p:cNvPr id="47" name="ocean:frame"/>
+          <p:cNvPr id="46" name="ocean:frame"/>
           <p:cNvSpPr/>
           <p:nvPr/>
         </p:nvSpPr>
@@ -13928,7 +13906,7 @@
       </p:sp>
       <p:sp>
         <p:nvSpPr>
-          <p:cNvPr id="48" name="Shape 44"/>
+          <p:cNvPr id="47" name="Shape 43"/>
           <p:cNvSpPr/>
           <p:nvPr/>
         </p:nvSpPr>
@@ -13953,7 +13931,7 @@
       </p:sp>
       <p:sp>
         <p:nvSpPr>
-          <p:cNvPr id="49" name="Shape 45"/>
+          <p:cNvPr id="48" name="Shape 44"/>
           <p:cNvSpPr/>
           <p:nvPr/>
         </p:nvSpPr>
@@ -13978,7 +13956,7 @@
       </p:sp>
       <p:sp>
         <p:nvSpPr>
-          <p:cNvPr id="50" name="Shape 46"/>
+          <p:cNvPr id="49" name="Shape 45"/>
           <p:cNvSpPr/>
           <p:nvPr/>
         </p:nvSpPr>
@@ -14003,7 +13981,7 @@
       </p:sp>
       <p:sp>
         <p:nvSpPr>
-          <p:cNvPr id="51" name="ocean:label"/>
+          <p:cNvPr id="50" name="ocean:label"/>
           <p:cNvSpPr/>
           <p:nvPr/>
         </p:nvSpPr>
@@ -14045,7 +14023,7 @@
       </p:sp>
       <p:sp>
         <p:nvSpPr>
-          <p:cNvPr id="52" name="ocean:body"/>
+          <p:cNvPr id="51" name="ocean:body"/>
           <p:cNvSpPr/>
           <p:nvPr/>
         </p:nvSpPr>
@@ -14082,6 +14060,48 @@
               <a:t>Confirm the agreed next action</a:t>
             </a:r>
             <a:endParaRPr lang="en-US" sz="1300" dirty="0"/>
+          </a:p>
+        </p:txBody>
+      </p:sp>
+      <p:sp>
+        <p:nvSpPr>
+          <p:cNvPr id="52" name="ocean:footer"/>
+          <p:cNvSpPr/>
+          <p:nvPr/>
+        </p:nvSpPr>
+        <p:spPr>
+          <a:xfrm>
+            <a:off x="548640" y="6419088"/>
+            <a:ext cx="7315200" cy="182880"/>
+          </a:xfrm>
+          <a:prstGeom prst="rect">
+            <a:avLst/>
+          </a:prstGeom>
+          <a:noFill/>
+          <a:ln/>
+        </p:spPr>
+        <p:txBody>
+          <a:bodyPr wrap="square" lIns="0" tIns="0" rIns="0" bIns="0" rtlCol="0" anchor="t"/>
+          <a:lstStyle/>
+          <a:p>
+            <a:pPr algn="l" indent="0" marL="0">
+              <a:lnSpc>
+                <a:spcPts val="1116"/>
+              </a:lnSpc>
+              <a:buNone/>
+            </a:pPr>
+            <a:r>
+              <a:rPr lang="en-US" sz="900" spc="225" kern="0" dirty="0">
+                <a:solidFill>
+                  <a:srgbClr val="0B1617"/>
+                </a:solidFill>
+                <a:latin typeface="Stack Sans Headline Light" pitchFamily="34" charset="0"/>
+                <a:ea typeface="Stack Sans Headline Light" pitchFamily="34" charset="-122"/>
+                <a:cs typeface="Stack Sans Headline Light" pitchFamily="34" charset="-120"/>
+              </a:rPr>
+              <a:t>OCEAN RCS · CONFIDENTIAL · DESIGN SPECIMEN · DO NOT USE</a:t>
+            </a:r>
+            <a:endParaRPr lang="en-US" sz="900" dirty="0"/>
           </a:p>
         </p:txBody>
       </p:sp>

</xml_diff>

<commit_message>
Retire old recipe references, combined notices in proposal templates, ChatGPT deck guardrails
- Stale: investor deck rules, starter notice, superseded prototype builders, and reference examples (report, contract, overview) that showed the old recipe, worded close and old footers
- Proposals: proposal classification, recipient and validity required for release; per-section stricter status; closing distribution notice; new proposal deck starter; Word contract template footer
- Decks: notice footer on agenda, dividers and key number; qa.py checks notices and 16:9 on any PPTX
- ChatGPT: rewritten project instructions and a new brand/DECK-CHECKLIST.md
</commit_message>
<xml_diff>
--- a/output/pptx/ocean-deck-recipe-10.pptx
+++ b/output/pptx/ocean-deck-recipe-10.pptx
@@ -3000,26 +3000,26 @@
         <p:spPr>
           <a:xfrm>
             <a:off x="512064" y="3026664"/>
-            <a:ext cx="2743200" cy="816737"/>
-          </a:xfrm>
-          <a:prstGeom prst="rect">
-            <a:avLst/>
-          </a:prstGeom>
-          <a:noFill/>
-          <a:ln/>
-        </p:spPr>
-        <p:txBody>
-          <a:bodyPr wrap="square" lIns="0" tIns="0" rIns="0" bIns="0" rtlCol="0" anchor="t"/>
-          <a:lstStyle/>
-          <a:p>
-            <a:pPr algn="l" indent="0" marL="0">
-              <a:lnSpc>
-                <a:spcPts val="6034"/>
-              </a:lnSpc>
-              <a:buNone/>
-            </a:pPr>
-            <a:r>
-              <a:rPr lang="en-US" sz="5839" spc="-350" kern="0" dirty="0">
+            <a:ext cx="2743200" cy="729425"/>
+          </a:xfrm>
+          <a:prstGeom prst="rect">
+            <a:avLst/>
+          </a:prstGeom>
+          <a:noFill/>
+          <a:ln/>
+        </p:spPr>
+        <p:txBody>
+          <a:bodyPr wrap="square" lIns="0" tIns="0" rIns="0" bIns="0" rtlCol="0" anchor="t"/>
+          <a:lstStyle/>
+          <a:p>
+            <a:pPr algn="l" indent="0" marL="0">
+              <a:lnSpc>
+                <a:spcPts val="5442"/>
+              </a:lnSpc>
+              <a:buNone/>
+            </a:pPr>
+            <a:r>
+              <a:rPr lang="en-US" sz="5266" spc="-316" kern="0" dirty="0">
                 <a:solidFill>
                   <a:srgbClr val="0B1617"/>
                 </a:solidFill>
@@ -3029,7 +3029,7 @@
               </a:rPr>
               <a:t>01</a:t>
             </a:r>
-            <a:endParaRPr lang="en-US" sz="5839" dirty="0"/>
+            <a:endParaRPr lang="en-US" sz="5266" dirty="0"/>
           </a:p>
         </p:txBody>
       </p:sp>
@@ -3084,7 +3084,7 @@
         <p:spPr>
           <a:xfrm>
             <a:off x="4425696" y="3364992"/>
-            <a:ext cx="7223760" cy="469265"/>
+            <a:ext cx="7223760" cy="433832"/>
           </a:xfrm>
           <a:prstGeom prst="rect">
             <a:avLst/>
@@ -3125,7 +3125,7 @@
         </p:nvSpPr>
         <p:spPr>
           <a:xfrm>
-            <a:off x="548640" y="3870833"/>
+            <a:off x="548640" y="3783521"/>
             <a:ext cx="11094415" cy="0"/>
           </a:xfrm>
           <a:prstGeom prst="line">
@@ -3148,27 +3148,27 @@
         </p:nvSpPr>
         <p:spPr>
           <a:xfrm>
-            <a:off x="512064" y="3916553"/>
-            <a:ext cx="2743200" cy="816737"/>
-          </a:xfrm>
-          <a:prstGeom prst="rect">
-            <a:avLst/>
-          </a:prstGeom>
-          <a:noFill/>
-          <a:ln/>
-        </p:spPr>
-        <p:txBody>
-          <a:bodyPr wrap="square" lIns="0" tIns="0" rIns="0" bIns="0" rtlCol="0" anchor="t"/>
-          <a:lstStyle/>
-          <a:p>
-            <a:pPr algn="l" indent="0" marL="0">
-              <a:lnSpc>
-                <a:spcPts val="6034"/>
-              </a:lnSpc>
-              <a:buNone/>
-            </a:pPr>
-            <a:r>
-              <a:rPr lang="en-US" sz="5839" spc="-350" kern="0" dirty="0">
+            <a:off x="512064" y="3829241"/>
+            <a:ext cx="2743200" cy="729425"/>
+          </a:xfrm>
+          <a:prstGeom prst="rect">
+            <a:avLst/>
+          </a:prstGeom>
+          <a:noFill/>
+          <a:ln/>
+        </p:spPr>
+        <p:txBody>
+          <a:bodyPr wrap="square" lIns="0" tIns="0" rIns="0" bIns="0" rtlCol="0" anchor="t"/>
+          <a:lstStyle/>
+          <a:p>
+            <a:pPr algn="l" indent="0" marL="0">
+              <a:lnSpc>
+                <a:spcPts val="5442"/>
+              </a:lnSpc>
+              <a:buNone/>
+            </a:pPr>
+            <a:r>
+              <a:rPr lang="en-US" sz="5266" spc="-316" kern="0" dirty="0">
                 <a:solidFill>
                   <a:srgbClr val="0B1617"/>
                 </a:solidFill>
@@ -3178,7 +3178,7 @@
               </a:rPr>
               <a:t>02</a:t>
             </a:r>
-            <a:endParaRPr lang="en-US" sz="5839" dirty="0"/>
+            <a:endParaRPr lang="en-US" sz="5266" dirty="0"/>
           </a:p>
         </p:txBody>
       </p:sp>
@@ -3190,7 +3190,7 @@
         </p:nvSpPr>
         <p:spPr>
           <a:xfrm>
-            <a:off x="4443984" y="4053713"/>
+            <a:off x="4443984" y="3966401"/>
             <a:ext cx="7132320" cy="200660"/>
           </a:xfrm>
           <a:prstGeom prst="rect">
@@ -3232,8 +3232,8 @@
         </p:nvSpPr>
         <p:spPr>
           <a:xfrm>
-            <a:off x="4425696" y="4254881"/>
-            <a:ext cx="7223760" cy="469265"/>
+            <a:off x="4425696" y="4167569"/>
+            <a:ext cx="7223760" cy="433832"/>
           </a:xfrm>
           <a:prstGeom prst="rect">
             <a:avLst/>
@@ -3274,7 +3274,7 @@
         </p:nvSpPr>
         <p:spPr>
           <a:xfrm>
-            <a:off x="548640" y="4760722"/>
+            <a:off x="548640" y="4586097"/>
             <a:ext cx="11094415" cy="0"/>
           </a:xfrm>
           <a:prstGeom prst="line">
@@ -3297,27 +3297,27 @@
         </p:nvSpPr>
         <p:spPr>
           <a:xfrm>
-            <a:off x="512064" y="4806442"/>
-            <a:ext cx="2743200" cy="816737"/>
-          </a:xfrm>
-          <a:prstGeom prst="rect">
-            <a:avLst/>
-          </a:prstGeom>
-          <a:noFill/>
-          <a:ln/>
-        </p:spPr>
-        <p:txBody>
-          <a:bodyPr wrap="square" lIns="0" tIns="0" rIns="0" bIns="0" rtlCol="0" anchor="t"/>
-          <a:lstStyle/>
-          <a:p>
-            <a:pPr algn="l" indent="0" marL="0">
-              <a:lnSpc>
-                <a:spcPts val="6034"/>
-              </a:lnSpc>
-              <a:buNone/>
-            </a:pPr>
-            <a:r>
-              <a:rPr lang="en-US" sz="5839" spc="-350" kern="0" dirty="0">
+            <a:off x="512064" y="4631817"/>
+            <a:ext cx="2743200" cy="729425"/>
+          </a:xfrm>
+          <a:prstGeom prst="rect">
+            <a:avLst/>
+          </a:prstGeom>
+          <a:noFill/>
+          <a:ln/>
+        </p:spPr>
+        <p:txBody>
+          <a:bodyPr wrap="square" lIns="0" tIns="0" rIns="0" bIns="0" rtlCol="0" anchor="t"/>
+          <a:lstStyle/>
+          <a:p>
+            <a:pPr algn="l" indent="0" marL="0">
+              <a:lnSpc>
+                <a:spcPts val="5442"/>
+              </a:lnSpc>
+              <a:buNone/>
+            </a:pPr>
+            <a:r>
+              <a:rPr lang="en-US" sz="5266" spc="-316" kern="0" dirty="0">
                 <a:solidFill>
                   <a:srgbClr val="0B1617"/>
                 </a:solidFill>
@@ -3327,7 +3327,7 @@
               </a:rPr>
               <a:t>03</a:t>
             </a:r>
-            <a:endParaRPr lang="en-US" sz="5839" dirty="0"/>
+            <a:endParaRPr lang="en-US" sz="5266" dirty="0"/>
           </a:p>
         </p:txBody>
       </p:sp>
@@ -3339,7 +3339,7 @@
         </p:nvSpPr>
         <p:spPr>
           <a:xfrm>
-            <a:off x="4443984" y="4943602"/>
+            <a:off x="4443984" y="4768977"/>
             <a:ext cx="7132320" cy="200660"/>
           </a:xfrm>
           <a:prstGeom prst="rect">
@@ -3381,8 +3381,8 @@
         </p:nvSpPr>
         <p:spPr>
           <a:xfrm>
-            <a:off x="4425696" y="5144770"/>
-            <a:ext cx="7223760" cy="469265"/>
+            <a:off x="4425696" y="4970145"/>
+            <a:ext cx="7223760" cy="433832"/>
           </a:xfrm>
           <a:prstGeom prst="rect">
             <a:avLst/>
@@ -3423,7 +3423,7 @@
         </p:nvSpPr>
         <p:spPr>
           <a:xfrm>
-            <a:off x="548640" y="5650611"/>
+            <a:off x="548640" y="5388674"/>
             <a:ext cx="11094415" cy="0"/>
           </a:xfrm>
           <a:prstGeom prst="line">
@@ -3446,27 +3446,27 @@
         </p:nvSpPr>
         <p:spPr>
           <a:xfrm>
-            <a:off x="512064" y="5696331"/>
-            <a:ext cx="2743200" cy="816737"/>
-          </a:xfrm>
-          <a:prstGeom prst="rect">
-            <a:avLst/>
-          </a:prstGeom>
-          <a:noFill/>
-          <a:ln/>
-        </p:spPr>
-        <p:txBody>
-          <a:bodyPr wrap="square" lIns="0" tIns="0" rIns="0" bIns="0" rtlCol="0" anchor="t"/>
-          <a:lstStyle/>
-          <a:p>
-            <a:pPr algn="l" indent="0" marL="0">
-              <a:lnSpc>
-                <a:spcPts val="6034"/>
-              </a:lnSpc>
-              <a:buNone/>
-            </a:pPr>
-            <a:r>
-              <a:rPr lang="en-US" sz="5839" spc="-350" kern="0" dirty="0">
+            <a:off x="512064" y="5434393"/>
+            <a:ext cx="2743200" cy="729425"/>
+          </a:xfrm>
+          <a:prstGeom prst="rect">
+            <a:avLst/>
+          </a:prstGeom>
+          <a:noFill/>
+          <a:ln/>
+        </p:spPr>
+        <p:txBody>
+          <a:bodyPr wrap="square" lIns="0" tIns="0" rIns="0" bIns="0" rtlCol="0" anchor="t"/>
+          <a:lstStyle/>
+          <a:p>
+            <a:pPr algn="l" indent="0" marL="0">
+              <a:lnSpc>
+                <a:spcPts val="5442"/>
+              </a:lnSpc>
+              <a:buNone/>
+            </a:pPr>
+            <a:r>
+              <a:rPr lang="en-US" sz="5266" spc="-316" kern="0" dirty="0">
                 <a:solidFill>
                   <a:srgbClr val="0B1617"/>
                 </a:solidFill>
@@ -3476,7 +3476,7 @@
               </a:rPr>
               <a:t>04</a:t>
             </a:r>
-            <a:endParaRPr lang="en-US" sz="5839" dirty="0"/>
+            <a:endParaRPr lang="en-US" sz="5266" dirty="0"/>
           </a:p>
         </p:txBody>
       </p:sp>
@@ -3488,7 +3488,7 @@
         </p:nvSpPr>
         <p:spPr>
           <a:xfrm>
-            <a:off x="4443984" y="5833491"/>
+            <a:off x="4443984" y="5571554"/>
             <a:ext cx="7132320" cy="200660"/>
           </a:xfrm>
           <a:prstGeom prst="rect">
@@ -3530,8 +3530,8 @@
         </p:nvSpPr>
         <p:spPr>
           <a:xfrm>
-            <a:off x="4425696" y="6034659"/>
-            <a:ext cx="7223760" cy="469265"/>
+            <a:off x="4425696" y="5772721"/>
+            <a:ext cx="7223760" cy="433832"/>
           </a:xfrm>
           <a:prstGeom prst="rect">
             <a:avLst/>
@@ -3572,7 +3572,7 @@
         </p:nvSpPr>
         <p:spPr>
           <a:xfrm>
-            <a:off x="548640" y="6540500"/>
+            <a:off x="548640" y="6191250"/>
             <a:ext cx="11094415" cy="0"/>
           </a:xfrm>
           <a:prstGeom prst="line">
@@ -3595,7 +3595,7 @@
         </p:nvSpPr>
         <p:spPr>
           <a:xfrm>
-            <a:off x="548640" y="6591300"/>
+            <a:off x="548640" y="6242050"/>
             <a:ext cx="11094415" cy="38100"/>
           </a:xfrm>
           <a:prstGeom prst="rect">
@@ -3611,6 +3611,48 @@
             <a:prstDash val="solid"/>
           </a:ln>
         </p:spPr>
+      </p:sp>
+      <p:sp>
+        <p:nvSpPr>
+          <p:cNvPr id="24" name="ocean:footer"/>
+          <p:cNvSpPr/>
+          <p:nvPr/>
+        </p:nvSpPr>
+        <p:spPr>
+          <a:xfrm>
+            <a:off x="548640" y="6419088"/>
+            <a:ext cx="7315200" cy="182880"/>
+          </a:xfrm>
+          <a:prstGeom prst="rect">
+            <a:avLst/>
+          </a:prstGeom>
+          <a:noFill/>
+          <a:ln/>
+        </p:spPr>
+        <p:txBody>
+          <a:bodyPr wrap="square" lIns="0" tIns="0" rIns="0" bIns="0" rtlCol="0" anchor="t"/>
+          <a:lstStyle/>
+          <a:p>
+            <a:pPr algn="l" indent="0" marL="0">
+              <a:lnSpc>
+                <a:spcPts val="1116"/>
+              </a:lnSpc>
+              <a:buNone/>
+            </a:pPr>
+            <a:r>
+              <a:rPr lang="en-US" sz="900" spc="225" kern="0" dirty="0">
+                <a:solidFill>
+                  <a:srgbClr val="0B1617"/>
+                </a:solidFill>
+                <a:latin typeface="Stack Sans Headline Light" pitchFamily="34" charset="0"/>
+                <a:ea typeface="Stack Sans Headline Light" pitchFamily="34" charset="-122"/>
+                <a:cs typeface="Stack Sans Headline Light" pitchFamily="34" charset="-120"/>
+              </a:rPr>
+              <a:t>OCEAN RCS · CONFIDENTIAL · DESIGN SPECIMEN · DO NOT USE</a:t>
+            </a:r>
+            <a:endParaRPr lang="en-US" sz="900" dirty="0"/>
+          </a:p>
+        </p:txBody>
       </p:sp>
     </p:spTree>
   </p:cSld>
@@ -12257,6 +12299,48 @@
               <a:t>ILLUSTRATIVE</a:t>
             </a:r>
             <a:endParaRPr lang="en-US" sz="1000" dirty="0"/>
+          </a:p>
+        </p:txBody>
+      </p:sp>
+      <p:sp>
+        <p:nvSpPr>
+          <p:cNvPr id="12" name="ocean:footer"/>
+          <p:cNvSpPr/>
+          <p:nvPr/>
+        </p:nvSpPr>
+        <p:spPr>
+          <a:xfrm>
+            <a:off x="548640" y="6419088"/>
+            <a:ext cx="7315200" cy="182880"/>
+          </a:xfrm>
+          <a:prstGeom prst="rect">
+            <a:avLst/>
+          </a:prstGeom>
+          <a:noFill/>
+          <a:ln/>
+        </p:spPr>
+        <p:txBody>
+          <a:bodyPr wrap="square" lIns="0" tIns="0" rIns="0" bIns="0" rtlCol="0" anchor="t"/>
+          <a:lstStyle/>
+          <a:p>
+            <a:pPr algn="l" indent="0" marL="0">
+              <a:lnSpc>
+                <a:spcPts val="1116"/>
+              </a:lnSpc>
+              <a:buNone/>
+            </a:pPr>
+            <a:r>
+              <a:rPr lang="en-US" sz="900" spc="225" kern="0" dirty="0">
+                <a:solidFill>
+                  <a:srgbClr val="F3FBF8"/>
+                </a:solidFill>
+                <a:latin typeface="Stack Sans Headline Light" pitchFamily="34" charset="0"/>
+                <a:ea typeface="Stack Sans Headline Light" pitchFamily="34" charset="-122"/>
+                <a:cs typeface="Stack Sans Headline Light" pitchFamily="34" charset="-120"/>
+              </a:rPr>
+              <a:t>OCEAN RCS · CONFIDENTIAL · DESIGN SPECIMEN · DO NOT USE</a:t>
+            </a:r>
+            <a:endParaRPr lang="en-US" sz="900" dirty="0"/>
           </a:p>
         </p:txBody>
       </p:sp>

</xml_diff>